<commit_message>
STMicroelectronics Q3 2026: add the silicon photonics ramp to the outlook and base case
Co-Authored-By: Claude Opus 5.5 <noreply@anthropic.com>
Claude-Session: https://claude.ai/code/session_014JFw9twk3me7qdaB3efhdc
</commit_message>
<xml_diff>
--- a/output/STMMI_Q32026/Earnings_Update_STMMI_Q32026.pptx
+++ b/output/STMMI_Q32026/Earnings_Update_STMMI_Q32026.pptx
@@ -2664,7 +2664,7 @@
         <p:spPr>
           <a:xfrm>
             <a:off x="658368" y="8036357"/>
-            <a:ext cx="6245352" cy="645871"/>
+            <a:ext cx="6245352" cy="802767"/>
           </a:xfrm>
           <a:prstGeom prst="rect">
             <a:avLst/>
@@ -2691,7 +2691,7 @@
                 <a:ea typeface="Nunito" pitchFamily="34" charset="-122"/>
                 <a:cs typeface="Nunito" pitchFamily="34" charset="-120"/>
               </a:rPr>
-              <a:t>We are constructive on STMicroelectronics. We underwrite a recovery led by AI datacenters, about USD 1.3bn of revenue this year and more than double in 2027, satellites and industrial, with gross margin rising from 39% toward the 44% to 46% model once four legacy fabs close in late 2027 or early 2028. Forward EPS of USD 2.48 is still 43% below the 2023 peak. At 19.9x, upgrades do the work. Next test: the January update with 2027 datacenter targets.</a:t>
+              <a:t>We are constructive on STMicroelectronics. We underwrite a recovery led by AI datacenters, about USD 1.3bn of revenue this year and more than double in 2027 as silicon photonics ramps, satellites and industrial, with gross margin rising from 39% toward the 44% to 46% model once four legacy fabs close in late 2027 or early 2028. Forward EPS of USD 2.48 is still 43% below the 2023 peak. At 19.9x, upgrades do the work. Next test: the January update with 2027 datacenter targets.</a:t>
             </a:r>
             <a:endParaRPr lang="en-US" sz="870" dirty="0"/>
           </a:p>
@@ -2705,7 +2705,7 @@
         </p:nvSpPr>
         <p:spPr>
           <a:xfrm>
-            <a:off x="658368" y="8761781"/>
+            <a:off x="658368" y="8918677"/>
             <a:ext cx="6245352" cy="0"/>
           </a:xfrm>
           <a:prstGeom prst="line">
@@ -2728,7 +2728,7 @@
         </p:nvSpPr>
         <p:spPr>
           <a:xfrm>
-            <a:off x="3781044" y="8871509"/>
+            <a:off x="3781044" y="9028405"/>
             <a:ext cx="0" cy="828751"/>
           </a:xfrm>
           <a:prstGeom prst="line">
@@ -2751,7 +2751,7 @@
         </p:nvSpPr>
         <p:spPr>
           <a:xfrm>
-            <a:off x="658368" y="8871509"/>
+            <a:off x="658368" y="9028405"/>
             <a:ext cx="2939796" cy="155448"/>
           </a:xfrm>
           <a:prstGeom prst="rect">
@@ -2790,7 +2790,7 @@
         </p:nvSpPr>
         <p:spPr>
           <a:xfrm>
-            <a:off x="658368" y="9063533"/>
+            <a:off x="658368" y="9220429"/>
             <a:ext cx="2939796" cy="627583"/>
           </a:xfrm>
           <a:prstGeom prst="rect">
@@ -2832,7 +2832,7 @@
         </p:nvSpPr>
         <p:spPr>
           <a:xfrm>
-            <a:off x="3963924" y="8871509"/>
+            <a:off x="3963924" y="9028405"/>
             <a:ext cx="2939796" cy="155448"/>
           </a:xfrm>
           <a:prstGeom prst="rect">
@@ -2871,7 +2871,7 @@
         </p:nvSpPr>
         <p:spPr>
           <a:xfrm>
-            <a:off x="3963924" y="9063533"/>
+            <a:off x="3963924" y="9220429"/>
             <a:ext cx="2939796" cy="627583"/>
           </a:xfrm>
           <a:prstGeom prst="rect">
@@ -2914,11 +2914,11 @@
         <p:spPr>
           <a:xfrm>
             <a:off x="539496" y="7725461"/>
-            <a:ext cx="6483096" cy="2038807"/>
+            <a:ext cx="6483096" cy="2195703"/>
           </a:xfrm>
           <a:prstGeom prst="roundRect">
             <a:avLst>
-              <a:gd name="adj" fmla="val 4485"/>
+              <a:gd name="adj" fmla="val 4164"/>
             </a:avLst>
           </a:prstGeom>
           <a:ln w="16510">
@@ -3324,7 +3324,7 @@
                 <a:ea typeface="Nunito" pitchFamily="34" charset="-122"/>
                 <a:cs typeface="Nunito" pitchFamily="34" charset="-120"/>
               </a:rPr>
-              <a:t>ST guides Q4 revenue of USD 4.15bn, up 10.5% sequentially and 24.7% on the year, 0.7% above consensus, and gross margin of 39.0%, 90bp above, still including about 40bp of unused-capacity charges and 30bp of reshaping costs. That implies 2026 revenue of about USD 14.5bn, up 22.8%. Datacenter revenue should reach about USD 1.3bn this year and more than double in 2027; satellite revenue should be at least as large next year, limited by capacity rather than demand. The 400bp structural margin gain from closing four legacy fabs lands as a step in late 2027 or early 2028. Opex rises in 2027, more slowly than sales.</a:t>
+              <a:t>ST guides Q4 revenue of USD 4.15bn, up 10.5% sequentially and 0.7% above consensus, and gross margin of 39.0%, 90bp above, still absorbing about 70bp of unused-capacity and reshaping costs. That implies 2026 revenue of about USD 14.5bn, up 22.8%. Datacenter revenue should reach about USD 1.3bn this year, mostly microcontrollers, silicon photonics and BiCMOS chips, and more than double in 2027, when photonics becomes tens of percent of it: management sees ST as probably the only 12-inch photonics producer at scale and will lift capacity more than fourfold. Satellite revenue should at least match 2026, limited by capacity. The 400bp fab gain lands in late 2027 or early 2028.</a:t>
             </a:r>
             <a:endParaRPr lang="en-US" sz="870" dirty="0"/>
           </a:p>

</xml_diff>

<commit_message>
STMicroelectronics Q3 2026: photonics takeaway on page 1 and photonics trigger in the base case box
Co-Authored-By: Claude Opus 5.5 <noreply@anthropic.com>
Claude-Session: https://claude.ai/code/session_014JFw9twk3me7qdaB3efhdc
</commit_message>
<xml_diff>
--- a/output/STMMI_Q32026/Earnings_Update_STMMI_Q32026.pptx
+++ b/output/STMMI_Q32026/Earnings_Update_STMMI_Q32026.pptx
@@ -1513,13 +1513,13 @@
             <a:r>
               <a:rPr lang="en-US" sz="700" b="1" spc="80" kern="0" dirty="0">
                 <a:solidFill>
-                  <a:srgbClr val="4B5F80"/>
-                </a:solidFill>
-                <a:latin typeface="Nunito" pitchFamily="34" charset="0"/>
-                <a:ea typeface="Nunito" pitchFamily="34" charset="-122"/>
-                <a:cs typeface="Nunito" pitchFamily="34" charset="-120"/>
-              </a:rPr>
-              <a:t>Mixed</a:t>
+                  <a:srgbClr val="3BAF90"/>
+                </a:solidFill>
+                <a:latin typeface="Nunito" pitchFamily="34" charset="0"/>
+                <a:ea typeface="Nunito" pitchFamily="34" charset="-122"/>
+                <a:cs typeface="Nunito" pitchFamily="34" charset="-120"/>
+              </a:rPr>
+              <a:t>Orders</a:t>
             </a:r>
             <a:endParaRPr lang="en-US" sz="700" dirty="0"/>
           </a:p>
@@ -1561,7 +1561,7 @@
                 <a:ea typeface="Nunito" pitchFamily="34" charset="-122"/>
                 <a:cs typeface="Nunito" pitchFamily="34" charset="-120"/>
               </a:rPr>
-              <a:t>Revenue beat consensus by 0.7% and gross margin by 30bp; adjusted EPS of USD 0.37 missed by 10%.</a:t>
+              <a:t>Book-to-bill well above 2 lifts the backlog above USD 20bn, about five quarters of revenue.</a:t>
             </a:r>
             <a:endParaRPr lang="en-US" sz="870" dirty="0"/>
           </a:p>
@@ -1600,7 +1600,7 @@
                 <a:ea typeface="Nunito" pitchFamily="34" charset="-122"/>
                 <a:cs typeface="Nunito" pitchFamily="34" charset="-120"/>
               </a:rPr>
-              <a:t>Orders</a:t>
+              <a:t>Photonics</a:t>
             </a:r>
             <a:endParaRPr lang="en-US" sz="700" dirty="0"/>
           </a:p>
@@ -1642,7 +1642,7 @@
                 <a:ea typeface="Nunito" pitchFamily="34" charset="-122"/>
                 <a:cs typeface="Nunito" pitchFamily="34" charset="-120"/>
               </a:rPr>
-              <a:t>Book-to-bill well above 2 lifts the backlog above USD 20bn, about five quarters of revenue.</a:t>
+              <a:t>Datacenter sales more than double in 2027 as silicon photonics capacity rises more than fourfold.</a:t>
             </a:r>
             <a:endParaRPr lang="en-US" sz="870" dirty="0"/>
           </a:p>
@@ -2818,7 +2818,7 @@
                 <a:ea typeface="Nunito" pitchFamily="34" charset="-122"/>
                 <a:cs typeface="Nunito" pitchFamily="34" charset="-120"/>
               </a:rPr>
-              <a:t>Q4 gross margin at or above 39% and a Q1 revenue guide at or above consensus despite 86 days; a 2027 datacenter target above USD 2.6bn in January; the four legacy fab closures confirmed on schedule.</a:t>
+              <a:t>Q4 gross margin at or above 39% and Q1 at consensus despite 86 days; a 2027 datacenter target above USD 2.6bn in January with a first photonics revenue figure; fab closures on schedule.</a:t>
             </a:r>
             <a:endParaRPr lang="en-US" sz="870" dirty="0"/>
           </a:p>

</xml_diff>

<commit_message>
STMicroelectronics Q3 2026: reaction updated to the 29 October close (+1.9%)
Co-Authored-By: Claude Opus 5.5 <noreply@anthropic.com>
Claude-Session: https://claude.ai/code/session_014JFw9twk3me7qdaB3efhdc
</commit_message>
<xml_diff>
--- a/output/STMMI_Q32026/Earnings_Update_STMMI_Q32026.pptx
+++ b/output/STMMI_Q32026/Earnings_Update_STMMI_Q32026.pptx
@@ -1723,7 +1723,7 @@
                 <a:ea typeface="Nunito" pitchFamily="34" charset="-122"/>
                 <a:cs typeface="Nunito" pitchFamily="34" charset="-120"/>
               </a:rPr>
-              <a:t>Shares 1.9% higher intraday on 29 October, after opening 1.3% lower before the call.</a:t>
+              <a:t>Shares closed 1.9% higher on 29 October, after opening 1.3% lower before the call.</a:t>
             </a:r>
             <a:endParaRPr lang="en-US" sz="870" dirty="0"/>
           </a:p>
@@ -2449,7 +2449,7 @@
                 <a:ea typeface="Nunito" pitchFamily="34" charset="-122"/>
                 <a:cs typeface="Nunito" pitchFamily="34" charset="-120"/>
               </a:rPr>
-              <a:t>Revenue beat consensus by 0.7% and gross margin by 30bp, but adjusted EPS missed by 10%; the shares opened 1.3% lower on 29 October, then traded 1.9% higher after the call. The call carried the day: book-to-bill well above 2, a Q4 margin guide 90bp above consensus and a Q1 held at consensus despite fewer days. The recovery now has visibility.</a:t>
+              <a:t>Revenue beat consensus by 0.7% and gross margin by 30bp, but adjusted EPS missed by 10%; the shares opened 1.3% lower on 29 October, then closed 1.9% higher. The call carried the day: book-to-bill well above 2, a Q4 margin guide 90bp above consensus and a Q1 held at consensus despite fewer days. The recovery now has visibility.</a:t>
             </a:r>
             <a:endParaRPr lang="en-US" sz="870" dirty="0"/>
           </a:p>
@@ -3243,7 +3243,7 @@
                 <a:ea typeface="Nunito" pitchFamily="34" charset="-122"/>
                 <a:cs typeface="Nunito" pitchFamily="34" charset="-120"/>
               </a:rPr>
-              <a:t>The reaction diverged from the EPS miss: the shares opened 1.3% lower on 29 October and were 1.9% higher intraday after the call. Confirmed drivers: adjusted operating income of USD 429m beat the estimate by 7%; book-to-bill was well above 2, and above 3 in communications and industrial; and management said it was comfortable delivering Q1 revenue and gross margin at least at consensus despite an 86-day quarter. We think positioning did the rest: the shares had fallen 42% from the June peak to EUR 39.45 a week earlier, taking the multiple to 18.1x.</a:t>
+              <a:t>The reaction diverged from the EPS miss: the shares opened 1.3% lower on 29 October and closed 1.9% higher after the call. Confirmed drivers: adjusted operating income of USD 429m beat the estimate by 7%; book-to-bill was well above 2, and above 3 in communications and industrial; and management said it was comfortable delivering Q1 revenue and gross margin at least at consensus despite an 86-day quarter. We think positioning did the rest: the shares had fallen 42% from the June peak to EUR 39.45 a week earlier, taking the multiple to 18.1x.</a:t>
             </a:r>
             <a:endParaRPr lang="en-US" sz="870" dirty="0"/>
           </a:p>
@@ -3458,7 +3458,7 @@
                 <a:ea typeface="Nunito" pitchFamily="34" charset="-122"/>
                 <a:cs typeface="Nunito" pitchFamily="34" charset="-120"/>
               </a:rPr>
-              <a:t>STMMI IM Equity, weekly, January 2014 to October 2026 (window starts after the 2009 loss and the 2012 to 2013 earnings trough) · BEst 12m-forward EPS in USD, price in EUR · 40-week simple MA · log scale · last price EUR 44.21 is a 29 October intraday level, after the release</a:t>
+              <a:t>STMMI IM Equity, weekly, January 2014 to October 2026 (window starts after the 2009 loss and the 2012 to 2013 earnings trough) · BEst 12m-forward EPS in USD, price in EUR · 40-week simple MA · log scale · last price EUR 44.21 is the 29 October close, after the release</a:t>
             </a:r>
             <a:endParaRPr lang="en-US" sz="700" dirty="0"/>
           </a:p>

</xml_diff>

<commit_message>
STMicroelectronics Q3 2026: reaction read against the Stoxx Europe 600 and its technology sector (+0.8%)
Co-Authored-By: Claude Opus 5.5 <noreply@anthropic.com>
Claude-Session: https://claude.ai/code/session_014JFw9twk3me7qdaB3efhdc
</commit_message>
<xml_diff>
--- a/output/STMMI_Q32026/Earnings_Update_STMMI_Q32026.pptx
+++ b/output/STMMI_Q32026/Earnings_Update_STMMI_Q32026.pptx
@@ -1723,7 +1723,7 @@
                 <a:ea typeface="Nunito" pitchFamily="34" charset="-122"/>
                 <a:cs typeface="Nunito" pitchFamily="34" charset="-120"/>
               </a:rPr>
-              <a:t>Shares closed 1.9% higher on 29 October, after opening 1.3% lower before the call.</a:t>
+              <a:t>Shares closed 1.9% higher on 29 October, against 0.8% for European tech, after a 1.3% lower open.</a:t>
             </a:r>
             <a:endParaRPr lang="en-US" sz="870" dirty="0"/>
           </a:p>
@@ -2449,7 +2449,7 @@
                 <a:ea typeface="Nunito" pitchFamily="34" charset="-122"/>
                 <a:cs typeface="Nunito" pitchFamily="34" charset="-120"/>
               </a:rPr>
-              <a:t>Revenue beat consensus by 0.7% and gross margin by 30bp, but adjusted EPS missed by 10%; the shares opened 1.3% lower on 29 October, then closed 1.9% higher. The call carried the day: book-to-bill well above 2, a Q4 margin guide 90bp above consensus and a Q1 held at consensus despite fewer days. The recovery now has visibility.</a:t>
+              <a:t>Revenue beat consensus by 0.7% and gross margin by 30bp, but adjusted EPS missed by 10%; the shares opened 1.3% lower on 29 October, then closed 1.9% higher, against 0.8% for European tech. The call carried the day: book-to-bill well above 2, a Q4 margin guide 90bp above consensus and a Q1 held at consensus despite fewer days.</a:t>
             </a:r>
             <a:endParaRPr lang="en-US" sz="870" dirty="0"/>
           </a:p>
@@ -3243,7 +3243,7 @@
                 <a:ea typeface="Nunito" pitchFamily="34" charset="-122"/>
                 <a:cs typeface="Nunito" pitchFamily="34" charset="-120"/>
               </a:rPr>
-              <a:t>The reaction diverged from the EPS miss: the shares opened 1.3% lower on 29 October and closed 1.9% higher after the call. Confirmed drivers: adjusted operating income of USD 429m beat the estimate by 7%; book-to-bill was well above 2, and above 3 in communications and industrial; and management said it was comfortable delivering Q1 revenue and gross margin at least at consensus despite an 86-day quarter. We think positioning did the rest: the shares had fallen 42% from the June peak to EUR 39.45 a week earlier, taking the multiple to 18.1x.</a:t>
+              <a:t>The reaction diverged from the EPS miss: the shares opened 1.3% lower on 29 October and closed 1.9% higher, against 0.8% for the Stoxx Europe 600 and its technology sector. Confirmed drivers: adjusted operating income of USD 429m beat the estimate by 7%; book-to-bill was well above 2, and above 3 in communications and industrial; and management said it was comfortable delivering Q1 revenue and gross margin at least at consensus despite an 86-day quarter. We think positioning did the rest: the shares had fallen 42% from the June peak to EUR 39.45 a week earlier, an 18.1x multiple.</a:t>
             </a:r>
             <a:endParaRPr lang="en-US" sz="870" dirty="0"/>
           </a:p>

</xml_diff>